<commit_message>
docs: standardize terminology from Personas to Behavioral Customer Segmentation across all decks and reports
</commit_message>
<xml_diff>
--- a/reports/retail_customer_behavior_presentation.pptx
+++ b/reports/retail_customer_behavior_presentation.pptx
@@ -6055,7 +6055,7 @@
               </a:defRPr>
             </a:pPr>
             <a:r>
-              <a:t>AI BEHAVIORAL MODELING</a:t>
+              <a:t>BEHAVIORAL MODELING</a:t>
             </a:r>
           </a:p>
         </p:txBody>
@@ -6090,7 +6090,7 @@
               </a:defRPr>
             </a:pPr>
             <a:r>
-              <a:t>Customer Personas: K-Means Clustering (k=4)</a:t>
+              <a:t>Behavioral Customer Segmentation (K-Means, k=4)</a:t>
             </a:r>
           </a:p>
           <a:p>
@@ -6102,7 +6102,7 @@
               </a:defRPr>
             </a:pPr>
             <a:r>
-              <a:t>Segmenting 3,900 customers into actionable personas using Age, Spend, and Order Depth.</a:t>
+              <a:t>Segmenting 3,900 customers into 4 actionable behavioral segments using Age, Spend, and Order Depth.</a:t>
             </a:r>
           </a:p>
         </p:txBody>
@@ -6180,7 +6180,7 @@
               </a:defRPr>
             </a:pPr>
             <a:r>
-              <a:t>Targeted Persona Strategies</a:t>
+              <a:t>Actionable Segment Strategies</a:t>
             </a:r>
           </a:p>
           <a:p>

</xml_diff>

<commit_message>
feat: align PowerPoint presentation 1-to-1 with HTML interactive presentation (exact 10 slides in identical sequence)
</commit_message>
<xml_diff>
--- a/reports/retail_customer_behavior_presentation.pptx
+++ b/reports/retail_customer_behavior_presentation.pptx
@@ -3397,7 +3397,7 @@
               </a:defRPr>
             </a:pPr>
             <a:r>
-              <a:t>EXECUTION PLAN</a:t>
+              <a:t>STRATEGIC ROADMAP &amp; ROI</a:t>
             </a:r>
           </a:p>
         </p:txBody>
@@ -3425,26 +3425,26 @@
           <a:lstStyle/>
           <a:p>
             <a:pPr>
-              <a:defRPr sz="2400" b="1">
+              <a:defRPr sz="2300" b="1">
                 <a:solidFill>
                   <a:srgbClr val="0F172A"/>
                 </a:solidFill>
               </a:defRPr>
             </a:pPr>
             <a:r>
-              <a:t>90-Day Strategic Roadmap &amp; Next Steps</a:t>
-            </a:r>
-          </a:p>
-          <a:p>
-            <a:pPr>
-              <a:defRPr sz="1300">
+              <a:t>Financial Forecast: Closing the Female Gap</a:t>
+            </a:r>
+          </a:p>
+          <a:p>
+            <a:pPr>
+              <a:defRPr sz="1250">
                 <a:solidFill>
                   <a:srgbClr val="64748B"/>
                 </a:solidFill>
               </a:defRPr>
             </a:pPr>
             <a:r>
-              <a:t>Structured quarterly milestones to capture female revenue and protect profit margins.</a:t>
+              <a:t>Simulated 12-month financial outcomes across three adoption scenarios and immediate actions.</a:t>
             </a:r>
           </a:p>
         </p:txBody>
@@ -3457,8 +3457,8 @@
         </p:nvSpPr>
         <p:spPr>
           <a:xfrm>
-            <a:off x="731520" y="1828800"/>
-            <a:ext cx="10698480" cy="1325880"/>
+            <a:off x="731520" y="1783080"/>
+            <a:ext cx="3474720" cy="2468880"/>
           </a:xfrm>
           <a:prstGeom prst="roundRect">
             <a:avLst/>
@@ -3466,7 +3466,7 @@
           <a:solidFill>
             <a:srgbClr val="FFFFFF"/>
           </a:solidFill>
-          <a:ln w="25400">
+          <a:ln w="31750">
             <a:solidFill>
               <a:srgbClr val="0284C7"/>
             </a:solidFill>
@@ -3491,59 +3491,59 @@
           <a:lstStyle/>
           <a:p>
             <a:pPr algn="ctr">
-              <a:defRPr sz="1400" b="1">
+              <a:defRPr sz="1100" b="1">
                 <a:solidFill>
                   <a:srgbClr val="0284C7"/>
                 </a:solidFill>
               </a:defRPr>
             </a:pPr>
             <a:r>
-              <a:t>DAYS 1 - 30: IMMEDIATE FIXES</a:t>
-            </a:r>
-          </a:p>
-          <a:p>
-            <a:pPr>
+              <a:t>CONSERVATIVE</a:t>
+            </a:r>
+          </a:p>
+          <a:p>
+            <a:pPr algn="ctr">
               <a:spcBef>
-                <a:spcPts val="300"/>
+                <a:spcPts val="400"/>
               </a:spcBef>
-              <a:defRPr sz="1100">
-                <a:solidFill>
-                  <a:srgbClr val="1E293B"/>
-                </a:solidFill>
-              </a:defRPr>
-            </a:pPr>
-            <a:r>
-              <a:t>• Halt blanket margin-eroding discounts across product catalog.</a:t>
-            </a:r>
-          </a:p>
-          <a:p>
-            <a:pPr>
+              <a:defRPr sz="2600" b="1">
+                <a:solidFill>
+                  <a:srgbClr val="0284C7"/>
+                </a:solidFill>
+              </a:defRPr>
+            </a:pPr>
+            <a:r>
+              <a:t>+$52,000</a:t>
+            </a:r>
+          </a:p>
+          <a:p>
+            <a:pPr algn="ctr">
               <a:spcBef>
-                <a:spcPts val="300"/>
+                <a:spcPts val="400"/>
               </a:spcBef>
-              <a:defRPr sz="1100">
-                <a:solidFill>
-                  <a:srgbClr val="1E293B"/>
-                </a:solidFill>
-              </a:defRPr>
-            </a:pPr>
-            <a:r>
-              <a:t>• Introduce a $75 minimum order threshold for free shipping perks.</a:t>
-            </a:r>
-          </a:p>
-          <a:p>
-            <a:pPr>
+              <a:defRPr sz="1100" b="1">
+                <a:solidFill>
+                  <a:srgbClr val="0F172A"/>
+                </a:solidFill>
+              </a:defRPr>
+            </a:pPr>
+            <a:r>
+              <a:t>25% Female Adoption</a:t>
+            </a:r>
+          </a:p>
+          <a:p>
+            <a:pPr algn="ctr">
               <a:spcBef>
-                <a:spcPts val="300"/>
+                <a:spcPts val="600"/>
               </a:spcBef>
-              <a:defRPr sz="1100">
-                <a:solidFill>
-                  <a:srgbClr val="1E293B"/>
-                </a:solidFill>
-              </a:defRPr>
-            </a:pPr>
-            <a:r>
-              <a:t>• Audit email automation to eliminate legacy male-only campaign targeting.</a:t>
+              <a:defRPr sz="950">
+                <a:solidFill>
+                  <a:srgbClr val="64748B"/>
+                </a:solidFill>
+              </a:defRPr>
+            </a:pPr>
+            <a:r>
+              <a:t>312 new subscribers, 2 additional annual baskets per member.</a:t>
             </a:r>
           </a:p>
         </p:txBody>
@@ -3556,8 +3556,8 @@
         </p:nvSpPr>
         <p:spPr>
           <a:xfrm>
-            <a:off x="731520" y="3337560"/>
-            <a:ext cx="10698480" cy="1325880"/>
+            <a:off x="4343400" y="1783080"/>
+            <a:ext cx="3474720" cy="2468880"/>
           </a:xfrm>
           <a:prstGeom prst="roundRect">
             <a:avLst/>
@@ -3565,7 +3565,7 @@
           <a:solidFill>
             <a:srgbClr val="FFFFFF"/>
           </a:solidFill>
-          <a:ln w="25400">
+          <a:ln w="31750">
             <a:solidFill>
               <a:srgbClr val="10B981"/>
             </a:solidFill>
@@ -3590,59 +3590,59 @@
           <a:lstStyle/>
           <a:p>
             <a:pPr algn="ctr">
-              <a:defRPr sz="1400" b="1">
+              <a:defRPr sz="1100" b="1">
                 <a:solidFill>
                   <a:srgbClr val="10B981"/>
                 </a:solidFill>
               </a:defRPr>
             </a:pPr>
             <a:r>
-              <a:t>DAYS 31 - 60: SUBSCRIPTION LAUNCH</a:t>
-            </a:r>
-          </a:p>
-          <a:p>
-            <a:pPr>
+              <a:t>MODERATE BENCHMARK</a:t>
+            </a:r>
+          </a:p>
+          <a:p>
+            <a:pPr algn="ctr">
               <a:spcBef>
-                <a:spcPts val="300"/>
+                <a:spcPts val="400"/>
               </a:spcBef>
-              <a:defRPr sz="1100">
-                <a:solidFill>
-                  <a:srgbClr val="1E293B"/>
-                </a:solidFill>
-              </a:defRPr>
-            </a:pPr>
-            <a:r>
-              <a:t>• Design and pilot curated Female Lifestyle &amp; Accessories Subscription.</a:t>
-            </a:r>
-          </a:p>
-          <a:p>
-            <a:pPr>
+              <a:defRPr sz="2600" b="1">
+                <a:solidFill>
+                  <a:srgbClr val="10B981"/>
+                </a:solidFill>
+              </a:defRPr>
+            </a:pPr>
+            <a:r>
+              <a:t>+$85,000</a:t>
+            </a:r>
+          </a:p>
+          <a:p>
+            <a:pPr algn="ctr">
               <a:spcBef>
-                <a:spcPts val="300"/>
+                <a:spcPts val="400"/>
               </a:spcBef>
-              <a:defRPr sz="1100">
-                <a:solidFill>
-                  <a:srgbClr val="1E293B"/>
-                </a:solidFill>
-              </a:defRPr>
-            </a:pPr>
-            <a:r>
-              <a:t>• Target initial 25% female cohort with personalized onboarding gifts.</a:t>
-            </a:r>
-          </a:p>
-          <a:p>
-            <a:pPr>
+              <a:defRPr sz="1100" b="1">
+                <a:solidFill>
+                  <a:srgbClr val="0F172A"/>
+                </a:solidFill>
+              </a:defRPr>
+            </a:pPr>
+            <a:r>
+              <a:t>40% Adoption (Matches Men)</a:t>
+            </a:r>
+          </a:p>
+          <a:p>
+            <a:pPr algn="ctr">
               <a:spcBef>
-                <a:spcPts val="300"/>
+                <a:spcPts val="600"/>
               </a:spcBef>
-              <a:defRPr sz="1100">
-                <a:solidFill>
-                  <a:srgbClr val="1E293B"/>
-                </a:solidFill>
-              </a:defRPr>
-            </a:pPr>
-            <a:r>
-              <a:t>• Integrate BOPIS (In-Store Pickup) VIP express lane for subscribers.</a:t>
+              <a:defRPr sz="950">
+                <a:solidFill>
+                  <a:srgbClr val="64748B"/>
+                </a:solidFill>
+              </a:defRPr>
+            </a:pPr>
+            <a:r>
+              <a:t>500 new subscribers, cross-category multi-item baskets.</a:t>
             </a:r>
           </a:p>
         </p:txBody>
@@ -3655,8 +3655,8 @@
         </p:nvSpPr>
         <p:spPr>
           <a:xfrm>
-            <a:off x="731520" y="4846320"/>
-            <a:ext cx="10698480" cy="1325880"/>
+            <a:off x="7955280" y="1783080"/>
+            <a:ext cx="3474720" cy="2468880"/>
           </a:xfrm>
           <a:prstGeom prst="roundRect">
             <a:avLst/>
@@ -3664,9 +3664,9 @@
           <a:solidFill>
             <a:srgbClr val="FFFFFF"/>
           </a:solidFill>
-          <a:ln w="25400">
+          <a:ln w="31750">
             <a:solidFill>
-              <a:srgbClr val="0D9488"/>
+              <a:srgbClr val="0F172A"/>
             </a:solidFill>
           </a:ln>
         </p:spPr>
@@ -3689,6 +3689,105 @@
           <a:lstStyle/>
           <a:p>
             <a:pPr algn="ctr">
+              <a:defRPr sz="1100" b="1">
+                <a:solidFill>
+                  <a:srgbClr val="0F172A"/>
+                </a:solidFill>
+              </a:defRPr>
+            </a:pPr>
+            <a:r>
+              <a:t>AGGRESSIVE</a:t>
+            </a:r>
+          </a:p>
+          <a:p>
+            <a:pPr algn="ctr">
+              <a:spcBef>
+                <a:spcPts val="400"/>
+              </a:spcBef>
+              <a:defRPr sz="2600" b="1">
+                <a:solidFill>
+                  <a:srgbClr val="0F172A"/>
+                </a:solidFill>
+              </a:defRPr>
+            </a:pPr>
+            <a:r>
+              <a:t>+$115,000</a:t>
+            </a:r>
+          </a:p>
+          <a:p>
+            <a:pPr algn="ctr">
+              <a:spcBef>
+                <a:spcPts val="400"/>
+              </a:spcBef>
+              <a:defRPr sz="1100" b="1">
+                <a:solidFill>
+                  <a:srgbClr val="0F172A"/>
+                </a:solidFill>
+              </a:defRPr>
+            </a:pPr>
+            <a:r>
+              <a:t>55% Market Penetration</a:t>
+            </a:r>
+          </a:p>
+          <a:p>
+            <a:pPr algn="ctr">
+              <a:spcBef>
+                <a:spcPts val="600"/>
+              </a:spcBef>
+              <a:defRPr sz="950">
+                <a:solidFill>
+                  <a:srgbClr val="64748B"/>
+                </a:solidFill>
+              </a:defRPr>
+            </a:pPr>
+            <a:r>
+              <a:t>Omni-Her VIP styling service, seasonal box membership.</a:t>
+            </a:r>
+          </a:p>
+        </p:txBody>
+      </p:sp>
+      <p:sp>
+        <p:nvSpPr>
+          <p:cNvPr id="9" name="Rounded Rectangle 8"/>
+          <p:cNvSpPr/>
+          <p:nvPr/>
+        </p:nvSpPr>
+        <p:spPr>
+          <a:xfrm>
+            <a:off x="731520" y="4434840"/>
+            <a:ext cx="10698480" cy="1828800"/>
+          </a:xfrm>
+          <a:prstGeom prst="roundRect">
+            <a:avLst/>
+          </a:prstGeom>
+          <a:solidFill>
+            <a:srgbClr val="0F172A"/>
+          </a:solidFill>
+          <a:ln>
+            <a:solidFill>
+              <a:srgbClr val="334155"/>
+            </a:solidFill>
+          </a:ln>
+        </p:spPr>
+        <p:style>
+          <a:lnRef idx="1">
+            <a:schemeClr val="accent1"/>
+          </a:lnRef>
+          <a:fillRef idx="3">
+            <a:schemeClr val="accent1"/>
+          </a:fillRef>
+          <a:effectRef idx="2">
+            <a:schemeClr val="accent1"/>
+          </a:effectRef>
+          <a:fontRef idx="minor">
+            <a:schemeClr val="lt1"/>
+          </a:fontRef>
+        </p:style>
+        <p:txBody>
+          <a:bodyPr rtlCol="0" anchor="ctr" wrap="square"/>
+          <a:lstStyle/>
+          <a:p>
+            <a:pPr algn="ctr">
               <a:defRPr sz="1400" b="1">
                 <a:solidFill>
                   <a:srgbClr val="0D9488"/>
@@ -3696,52 +3795,52 @@
               </a:defRPr>
             </a:pPr>
             <a:r>
-              <a:t>DAYS 61 - 90: AI SCALING &amp; CRM</a:t>
+              <a:t>IMMEDIATE 90-DAY STRATEGIC EXECUTION ACTIONS</a:t>
             </a:r>
           </a:p>
           <a:p>
             <a:pPr>
               <a:spcBef>
-                <a:spcPts val="300"/>
+                <a:spcPts val="600"/>
               </a:spcBef>
-              <a:defRPr sz="1100">
-                <a:solidFill>
-                  <a:srgbClr val="1E293B"/>
-                </a:solidFill>
-              </a:defRPr>
-            </a:pPr>
-            <a:r>
-              <a:t>• Deploy K-Means customer segmentation into marketing CRM.</a:t>
+              <a:defRPr sz="1150">
+                <a:solidFill>
+                  <a:srgbClr val="E2E8F0"/>
+                </a:solidFill>
+              </a:defRPr>
+            </a:pPr>
+            <a:r>
+              <a:t>• Phase 1 (Days 1–30): Sunset blanket promo codes in favor of $75+ spend thresholds. Audit legacy male-only email lists.</a:t>
             </a:r>
           </a:p>
           <a:p>
             <a:pPr>
               <a:spcBef>
-                <a:spcPts val="300"/>
+                <a:spcPts val="600"/>
               </a:spcBef>
-              <a:defRPr sz="1100">
-                <a:solidFill>
-                  <a:srgbClr val="1E293B"/>
-                </a:solidFill>
-              </a:defRPr>
-            </a:pPr>
-            <a:r>
-              <a:t>• Automate replenishment triggers based on past purchase frequency.</a:t>
+              <a:defRPr sz="1150">
+                <a:solidFill>
+                  <a:srgbClr val="E2E8F0"/>
+                </a:solidFill>
+              </a:defRPr>
+            </a:pPr>
+            <a:r>
+              <a:t>• Phase 2 (Days 31–60): Launch curated female lifestyle subscription pilot. Target initial 25% female cohort with onboarding gifts.</a:t>
             </a:r>
           </a:p>
           <a:p>
             <a:pPr>
               <a:spcBef>
-                <a:spcPts val="300"/>
+                <a:spcPts val="600"/>
               </a:spcBef>
-              <a:defRPr sz="1100">
-                <a:solidFill>
-                  <a:srgbClr val="1E293B"/>
-                </a:solidFill>
-              </a:defRPr>
-            </a:pPr>
-            <a:r>
-              <a:t>• Launch Platinum concierge loyalty tier for 46+ order champions.</a:t>
+              <a:defRPr sz="1150">
+                <a:solidFill>
+                  <a:srgbClr val="E2E8F0"/>
+                </a:solidFill>
+              </a:defRPr>
+            </a:pPr>
+            <a:r>
+              <a:t>• Phase 3 (Days 61–90): Operationalize K-Means behavioral segments into marketing CRM. Roll out VIP concierge loyalty tier.</a:t>
             </a:r>
           </a:p>
         </p:txBody>
@@ -3908,7 +4007,7 @@
           <a:lstStyle/>
           <a:p>
             <a:pPr>
-              <a:defRPr sz="2400" b="1">
+              <a:defRPr sz="2300" b="1">
                 <a:solidFill>
                   <a:srgbClr val="0F172A"/>
                 </a:solidFill>
@@ -3920,7 +4019,7 @@
           </a:p>
           <a:p>
             <a:pPr>
-              <a:defRPr sz="1300">
+              <a:defRPr sz="1250">
                 <a:solidFill>
                   <a:srgbClr val="64748B"/>
                 </a:solidFill>
@@ -3941,7 +4040,7 @@
         <p:spPr>
           <a:xfrm>
             <a:off x="731520" y="1828800"/>
-            <a:ext cx="2560320" cy="1645920"/>
+            <a:ext cx="2560320" cy="1554480"/>
           </a:xfrm>
           <a:prstGeom prst="roundRect">
             <a:avLst/>
@@ -3974,7 +4073,7 @@
           <a:lstStyle/>
           <a:p>
             <a:pPr algn="ctr">
-              <a:defRPr sz="1100" b="1">
+              <a:defRPr sz="1000" b="1">
                 <a:solidFill>
                   <a:srgbClr val="64748B"/>
                 </a:solidFill>
@@ -3986,7 +4085,7 @@
           </a:p>
           <a:p>
             <a:pPr algn="ctr">
-              <a:defRPr sz="2600" b="1">
+              <a:defRPr sz="2500" b="1">
                 <a:solidFill>
                   <a:srgbClr val="0F172A"/>
                 </a:solidFill>
@@ -3998,7 +4097,7 @@
           </a:p>
           <a:p>
             <a:pPr algn="ctr">
-              <a:defRPr sz="1000">
+              <a:defRPr sz="950">
                 <a:solidFill>
                   <a:srgbClr val="64748B"/>
                 </a:solidFill>
@@ -4019,7 +4118,7 @@
         <p:spPr>
           <a:xfrm>
             <a:off x="3429000" y="1828800"/>
-            <a:ext cx="2560320" cy="1645920"/>
+            <a:ext cx="2560320" cy="1554480"/>
           </a:xfrm>
           <a:prstGeom prst="roundRect">
             <a:avLst/>
@@ -4052,7 +4151,7 @@
           <a:lstStyle/>
           <a:p>
             <a:pPr algn="ctr">
-              <a:defRPr sz="1100" b="1">
+              <a:defRPr sz="1000" b="1">
                 <a:solidFill>
                   <a:srgbClr val="64748B"/>
                 </a:solidFill>
@@ -4064,7 +4163,7 @@
           </a:p>
           <a:p>
             <a:pPr algn="ctr">
-              <a:defRPr sz="2600" b="1">
+              <a:defRPr sz="2500" b="1">
                 <a:solidFill>
                   <a:srgbClr val="0F172A"/>
                 </a:solidFill>
@@ -4076,7 +4175,7 @@
           </a:p>
           <a:p>
             <a:pPr algn="ctr">
-              <a:defRPr sz="1000">
+              <a:defRPr sz="950">
                 <a:solidFill>
                   <a:srgbClr val="64748B"/>
                 </a:solidFill>
@@ -4097,7 +4196,7 @@
         <p:spPr>
           <a:xfrm>
             <a:off x="6126480" y="1828800"/>
-            <a:ext cx="2560320" cy="1645920"/>
+            <a:ext cx="2560320" cy="1554480"/>
           </a:xfrm>
           <a:prstGeom prst="roundRect">
             <a:avLst/>
@@ -4130,7 +4229,7 @@
           <a:lstStyle/>
           <a:p>
             <a:pPr algn="ctr">
-              <a:defRPr sz="1100" b="1">
+              <a:defRPr sz="1000" b="1">
                 <a:solidFill>
                   <a:srgbClr val="64748B"/>
                 </a:solidFill>
@@ -4142,7 +4241,7 @@
           </a:p>
           <a:p>
             <a:pPr algn="ctr">
-              <a:defRPr sz="2600" b="1">
+              <a:defRPr sz="2500" b="1">
                 <a:solidFill>
                   <a:srgbClr val="0F172A"/>
                 </a:solidFill>
@@ -4154,7 +4253,7 @@
           </a:p>
           <a:p>
             <a:pPr algn="ctr">
-              <a:defRPr sz="1000">
+              <a:defRPr sz="950">
                 <a:solidFill>
                   <a:srgbClr val="64748B"/>
                 </a:solidFill>
@@ -4175,7 +4274,7 @@
         <p:spPr>
           <a:xfrm>
             <a:off x="8823960" y="1828800"/>
-            <a:ext cx="2560320" cy="1645920"/>
+            <a:ext cx="2560320" cy="1554480"/>
           </a:xfrm>
           <a:prstGeom prst="roundRect">
             <a:avLst/>
@@ -4208,7 +4307,7 @@
           <a:lstStyle/>
           <a:p>
             <a:pPr algn="ctr">
-              <a:defRPr sz="1100" b="1">
+              <a:defRPr sz="1000" b="1">
                 <a:solidFill>
                   <a:srgbClr val="64748B"/>
                 </a:solidFill>
@@ -4220,7 +4319,7 @@
           </a:p>
           <a:p>
             <a:pPr algn="ctr">
-              <a:defRPr sz="2600" b="1">
+              <a:defRPr sz="2500" b="1">
                 <a:solidFill>
                   <a:srgbClr val="0F172A"/>
                 </a:solidFill>
@@ -4232,7 +4331,7 @@
           </a:p>
           <a:p>
             <a:pPr algn="ctr">
-              <a:defRPr sz="1000">
+              <a:defRPr sz="950">
                 <a:solidFill>
                   <a:srgbClr val="64748B"/>
                 </a:solidFill>
@@ -4252,8 +4351,8 @@
         </p:nvSpPr>
         <p:spPr>
           <a:xfrm>
-            <a:off x="731520" y="3840480"/>
-            <a:ext cx="5257800" cy="2286000"/>
+            <a:off x="731520" y="3657600"/>
+            <a:ext cx="5257800" cy="2468880"/>
           </a:xfrm>
           <a:prstGeom prst="roundRect">
             <a:avLst/>
@@ -4286,7 +4385,7 @@
           <a:lstStyle/>
           <a:p>
             <a:pPr algn="ctr">
-              <a:defRPr sz="1600" b="1">
+              <a:defRPr sz="1500" b="1">
                 <a:solidFill>
                   <a:srgbClr val="0F172A"/>
                 </a:solidFill>
@@ -4301,7 +4400,7 @@
               <a:spcBef>
                 <a:spcPts val="800"/>
               </a:spcBef>
-              <a:defRPr sz="1200">
+              <a:defRPr sz="1150">
                 <a:solidFill>
                   <a:srgbClr val="1E293B"/>
                 </a:solidFill>
@@ -4316,7 +4415,7 @@
               <a:spcBef>
                 <a:spcPts val="800"/>
               </a:spcBef>
-              <a:defRPr sz="1200">
+              <a:defRPr sz="1150">
                 <a:solidFill>
                   <a:srgbClr val="1E293B"/>
                 </a:solidFill>
@@ -4331,7 +4430,7 @@
               <a:spcBef>
                 <a:spcPts val="800"/>
               </a:spcBef>
-              <a:defRPr sz="1200">
+              <a:defRPr sz="1150">
                 <a:solidFill>
                   <a:srgbClr val="1E293B"/>
                 </a:solidFill>
@@ -4351,8 +4450,8 @@
         </p:nvSpPr>
         <p:spPr>
           <a:xfrm>
-            <a:off x="6217920" y="3840480"/>
-            <a:ext cx="5257800" cy="2286000"/>
+            <a:off x="6217920" y="3657600"/>
+            <a:ext cx="5257800" cy="2468880"/>
           </a:xfrm>
           <a:prstGeom prst="roundRect">
             <a:avLst/>
@@ -4385,7 +4484,7 @@
           <a:lstStyle/>
           <a:p>
             <a:pPr algn="ctr">
-              <a:defRPr sz="1600" b="1">
+              <a:defRPr sz="1500" b="1">
                 <a:solidFill>
                   <a:srgbClr val="EF4444"/>
                 </a:solidFill>
@@ -4400,7 +4499,7 @@
               <a:spcBef>
                 <a:spcPts val="800"/>
               </a:spcBef>
-              <a:defRPr sz="1200">
+              <a:defRPr sz="1150">
                 <a:solidFill>
                   <a:srgbClr val="1E293B"/>
                 </a:solidFill>
@@ -4415,7 +4514,7 @@
               <a:spcBef>
                 <a:spcPts val="800"/>
               </a:spcBef>
-              <a:defRPr sz="1200">
+              <a:defRPr sz="1150">
                 <a:solidFill>
                   <a:srgbClr val="1E293B"/>
                 </a:solidFill>
@@ -4430,7 +4529,7 @@
               <a:spcBef>
                 <a:spcPts val="800"/>
               </a:spcBef>
-              <a:defRPr sz="1200">
+              <a:defRPr sz="1150">
                 <a:solidFill>
                   <a:srgbClr val="1E293B"/>
                 </a:solidFill>
@@ -4576,7 +4675,7 @@
               </a:defRPr>
             </a:pPr>
             <a:r>
-              <a:t>STRATEGIC FOUNDATION</a:t>
+              <a:t>ANALYTICAL FRAMEWORK</a:t>
             </a:r>
           </a:p>
         </p:txBody>
@@ -4604,26 +4703,26 @@
           <a:lstStyle/>
           <a:p>
             <a:pPr>
-              <a:defRPr sz="2400" b="1">
+              <a:defRPr sz="2300" b="1">
                 <a:solidFill>
                   <a:srgbClr val="0F172A"/>
                 </a:solidFill>
               </a:defRPr>
             </a:pPr>
             <a:r>
-              <a:t>Historical Business Model: Legacy Men's Grooming Roots</a:t>
-            </a:r>
-          </a:p>
-          <a:p>
-            <a:pPr>
-              <a:defRPr sz="1300">
+              <a:t>How Data Solved the 7 Core Business Hypotheses</a:t>
+            </a:r>
+          </a:p>
+          <a:p>
+            <a:pPr>
+              <a:defRPr sz="1250">
                 <a:solidFill>
                   <a:srgbClr val="64748B"/>
                 </a:solidFill>
               </a:defRPr>
             </a:pPr>
             <a:r>
-              <a:t>Why 100% of subscribers and promotional discounts belong exclusively to male accounts.</a:t>
+              <a:t>Translating leadership's overarching mandate into empirical testable questions.</a:t>
             </a:r>
           </a:p>
         </p:txBody>
@@ -4637,7 +4736,7 @@
         <p:spPr>
           <a:xfrm>
             <a:off x="731520" y="1828800"/>
-            <a:ext cx="5120640" cy="4389120"/>
+            <a:ext cx="5257800" cy="4389120"/>
           </a:xfrm>
           <a:prstGeom prst="roundRect">
             <a:avLst/>
@@ -4645,9 +4744,9 @@
           <a:solidFill>
             <a:srgbClr val="FFFFFF"/>
           </a:solidFill>
-          <a:ln w="19050">
+          <a:ln>
             <a:solidFill>
-              <a:srgbClr val="0D9488"/>
+              <a:srgbClr val="E2E8F0"/>
             </a:solidFill>
           </a:ln>
         </p:spPr>
@@ -4670,14 +4769,41 @@
           <a:lstStyle/>
           <a:p>
             <a:pPr algn="ctr">
-              <a:defRPr sz="1800" b="1">
-                <a:solidFill>
-                  <a:srgbClr val="0F172A"/>
-                </a:solidFill>
-              </a:defRPr>
-            </a:pPr>
-            <a:r>
-              <a:t>The Business Evolution Story</a:t>
+              <a:spcBef>
+                <a:spcPts val="0"/>
+              </a:spcBef>
+              <a:defRPr sz="1300" b="1">
+                <a:solidFill>
+                  <a:srgbClr val="0D9488"/>
+                </a:solidFill>
+              </a:defRPr>
+            </a:pPr>
+            <a:r>
+              <a:t>1. H1: Commercial Performance</a:t>
+            </a:r>
+          </a:p>
+          <a:p>
+            <a:pPr>
+              <a:defRPr sz="1050" i="1">
+                <a:solidFill>
+                  <a:srgbClr val="64748B"/>
+                </a:solidFill>
+              </a:defRPr>
+            </a:pPr>
+            <a:r>
+              <a:t>Question: Where is revenue concentrated?</a:t>
+            </a:r>
+          </a:p>
+          <a:p>
+            <a:pPr>
+              <a:defRPr sz="1100">
+                <a:solidFill>
+                  <a:srgbClr val="1E293B"/>
+                </a:solidFill>
+              </a:defRPr>
+            </a:pPr>
+            <a:r>
+              <a:t>PROVED: Apparel drives 44.7%, Senior cohort (51-70) generates $88.5K.</a:t>
             </a:r>
           </a:p>
           <a:p>
@@ -4685,14 +4811,38 @@
               <a:spcBef>
                 <a:spcPts val="1000"/>
               </a:spcBef>
-              <a:defRPr sz="1200">
+              <a:defRPr sz="1300" b="1">
+                <a:solidFill>
+                  <a:srgbClr val="EF4444"/>
+                </a:solidFill>
+              </a:defRPr>
+            </a:pPr>
+            <a:r>
+              <a:t>2. H2: The Discount Stimulus Fallacy</a:t>
+            </a:r>
+          </a:p>
+          <a:p>
+            <a:pPr>
+              <a:defRPr sz="1050" i="1">
+                <a:solidFill>
+                  <a:srgbClr val="64748B"/>
+                </a:solidFill>
+              </a:defRPr>
+            </a:pPr>
+            <a:r>
+              <a:t>Question: Do discounts lift spend?</a:t>
+            </a:r>
+          </a:p>
+          <a:p>
+            <a:pPr>
+              <a:defRPr sz="1100">
                 <a:solidFill>
                   <a:srgbClr val="1E293B"/>
                 </a:solidFill>
               </a:defRPr>
             </a:pPr>
             <a:r>
-              <a:t>The empirical structure of the database reveals a strict chronological split: Customers #1 to #2,652 are all Male, while Customers #2,653 to #3,900 are all Female.</a:t>
+              <a:t>DISPROVED: Discounted AOV is $0.85 lower; zero basket expansion.</a:t>
             </a:r>
           </a:p>
           <a:p>
@@ -4700,44 +4850,38 @@
               <a:spcBef>
                 <a:spcPts val="1000"/>
               </a:spcBef>
-              <a:defRPr sz="1200">
+              <a:defRPr sz="1300" b="1">
+                <a:solidFill>
+                  <a:srgbClr val="F59E0B"/>
+                </a:solidFill>
+              </a:defRPr>
+            </a:pPr>
+            <a:r>
+              <a:t>3. H3: Loyalty Program Equity</a:t>
+            </a:r>
+          </a:p>
+          <a:p>
+            <a:pPr>
+              <a:defRPr sz="1050" i="1">
+                <a:solidFill>
+                  <a:srgbClr val="64748B"/>
+                </a:solidFill>
+              </a:defRPr>
+            </a:pPr>
+            <a:r>
+              <a:t>Question: Are subscriptions reaching all shoppers?</a:t>
+            </a:r>
+          </a:p>
+          <a:p>
+            <a:pPr>
+              <a:defRPr sz="1100">
                 <a:solidFill>
                   <a:srgbClr val="1E293B"/>
                 </a:solidFill>
               </a:defRPr>
             </a:pPr>
             <a:r>
-              <a:t>The enterprise originated as a dedicated Men's Grooming &amp; Shaving Subscription Club (analogous to Dollar Shave Club), where recurring deliveries were tailored exclusively to men.</a:t>
-            </a:r>
-          </a:p>
-          <a:p>
-            <a:pPr>
-              <a:spcBef>
-                <a:spcPts val="1000"/>
-              </a:spcBef>
-              <a:defRPr sz="1200">
-                <a:solidFill>
-                  <a:srgbClr val="1E293B"/>
-                </a:solidFill>
-              </a:defRPr>
-            </a:pPr>
-            <a:r>
-              <a:t>Upon successfully expanding the catalog into general lifestyle apparel (adding Dresses, Blouses, Skirts, and Jewelry), subscription privileges and automated discount codes remained grandfathered in the legacy male database.</a:t>
-            </a:r>
-          </a:p>
-          <a:p>
-            <a:pPr>
-              <a:spcBef>
-                <a:spcPts val="1000"/>
-              </a:spcBef>
-              <a:defRPr sz="1200">
-                <a:solidFill>
-                  <a:srgbClr val="1E293B"/>
-                </a:solidFill>
-              </a:defRPr>
-            </a:pPr>
-            <a:r>
-              <a:t>Incoming female shoppers entered organically as full-price retail customers, creating an apparent demographic anomaly that is actually a massive commercial opportunity.</a:t>
+              <a:t>DISPROVED: 0% of females enrolled vs 39.7% of males.</a:t>
             </a:r>
           </a:p>
         </p:txBody>
@@ -4750,8 +4894,8 @@
         </p:nvSpPr>
         <p:spPr>
           <a:xfrm>
-            <a:off x="6126480" y="1828800"/>
-            <a:ext cx="5303520" cy="1325880"/>
+            <a:off x="6217920" y="1828800"/>
+            <a:ext cx="5257800" cy="4389120"/>
           </a:xfrm>
           <a:prstGeom prst="roundRect">
             <a:avLst/>
@@ -4759,9 +4903,9 @@
           <a:solidFill>
             <a:srgbClr val="FFFFFF"/>
           </a:solidFill>
-          <a:ln w="25400">
+          <a:ln>
             <a:solidFill>
-              <a:srgbClr val="0D9488"/>
+              <a:srgbClr val="E2E8F0"/>
             </a:solidFill>
           </a:ln>
         </p:spPr>
@@ -4784,21 +4928,111 @@
           <a:lstStyle/>
           <a:p>
             <a:pPr algn="ctr">
-              <a:defRPr sz="1400" b="1">
+              <a:spcBef>
+                <a:spcPts val="0"/>
+              </a:spcBef>
+              <a:defRPr sz="1300" b="1">
+                <a:solidFill>
+                  <a:srgbClr val="0284C7"/>
+                </a:solidFill>
+              </a:defRPr>
+            </a:pPr>
+            <a:r>
+              <a:t>4. H4: Seasonality Allocation</a:t>
+            </a:r>
+          </a:p>
+          <a:p>
+            <a:pPr>
+              <a:defRPr sz="1050" i="1">
+                <a:solidFill>
+                  <a:srgbClr val="64748B"/>
+                </a:solidFill>
+              </a:defRPr>
+            </a:pPr>
+            <a:r>
+              <a:t>Question: When should inventory peak?</a:t>
+            </a:r>
+          </a:p>
+          <a:p>
+            <a:pPr>
+              <a:defRPr sz="1100">
+                <a:solidFill>
+                  <a:srgbClr val="1E293B"/>
+                </a:solidFill>
+              </a:defRPr>
+            </a:pPr>
+            <a:r>
+              <a:t>PROVED: Spring surge ($27.6K) and Winter ($27.2K) demand early procurement.</a:t>
+            </a:r>
+          </a:p>
+          <a:p>
+            <a:pPr>
+              <a:spcBef>
+                <a:spcPts val="1000"/>
+              </a:spcBef>
+              <a:defRPr sz="1300" b="1">
+                <a:solidFill>
+                  <a:srgbClr val="10B981"/>
+                </a:solidFill>
+              </a:defRPr>
+            </a:pPr>
+            <a:r>
+              <a:t>5. H5: Retention ROI (CLV)</a:t>
+            </a:r>
+          </a:p>
+          <a:p>
+            <a:pPr>
+              <a:defRPr sz="1050" i="1">
+                <a:solidFill>
+                  <a:srgbClr val="64748B"/>
+                </a:solidFill>
+              </a:defRPr>
+            </a:pPr>
+            <a:r>
+              <a:t>Question: Is repeat retention worth the cost?</a:t>
+            </a:r>
+          </a:p>
+          <a:p>
+            <a:pPr>
+              <a:defRPr sz="1100">
+                <a:solidFill>
+                  <a:srgbClr val="1E293B"/>
+                </a:solidFill>
+              </a:defRPr>
+            </a:pPr>
+            <a:r>
+              <a:t>PROVED: Platinum customers yield 6x more lifetime value ($3,027 vs $526).</a:t>
+            </a:r>
+          </a:p>
+          <a:p>
+            <a:pPr>
+              <a:spcBef>
+                <a:spcPts val="1000"/>
+              </a:spcBef>
+              <a:defRPr sz="1300" b="1">
                 <a:solidFill>
                   <a:srgbClr val="0D9488"/>
                 </a:solidFill>
               </a:defRPr>
             </a:pPr>
             <a:r>
-              <a:t>1. 100% Male Subscription Penetration</a:t>
-            </a:r>
-          </a:p>
-          <a:p>
-            <a:pPr>
-              <a:spcBef>
-                <a:spcPts val="400"/>
-              </a:spcBef>
+              <a:t>6. H6 &amp; H7: Omnichannel &amp; Behavioral Segmentation</a:t>
+            </a:r>
+          </a:p>
+          <a:p>
+            <a:pPr>
+              <a:defRPr sz="1050" i="1">
+                <a:solidFill>
+                  <a:srgbClr val="64748B"/>
+                </a:solidFill>
+              </a:defRPr>
+            </a:pPr>
+            <a:r>
+              <a:t>Question: How do channels and clusters behave?</a:t>
+            </a:r>
+          </a:p>
+          <a:p>
+            <a:pPr>
               <a:defRPr sz="1100">
                 <a:solidFill>
                   <a:srgbClr val="1E293B"/>
@@ -4806,145 +5040,7 @@
               </a:defRPr>
             </a:pPr>
             <a:r>
-              <a:t>All 1,053 subscribers are male. Shaving &amp; grooming routines represent the classic high-frequency, male-oriented direct-to-consumer subscription model.</a:t>
-            </a:r>
-          </a:p>
-        </p:txBody>
-      </p:sp>
-      <p:sp>
-        <p:nvSpPr>
-          <p:cNvPr id="8" name="Rounded Rectangle 7"/>
-          <p:cNvSpPr/>
-          <p:nvPr/>
-        </p:nvSpPr>
-        <p:spPr>
-          <a:xfrm>
-            <a:off x="6126480" y="3337560"/>
-            <a:ext cx="5303520" cy="1325880"/>
-          </a:xfrm>
-          <a:prstGeom prst="roundRect">
-            <a:avLst/>
-          </a:prstGeom>
-          <a:solidFill>
-            <a:srgbClr val="FFFFFF"/>
-          </a:solidFill>
-          <a:ln w="25400">
-            <a:solidFill>
-              <a:srgbClr val="0284C7"/>
-            </a:solidFill>
-          </a:ln>
-        </p:spPr>
-        <p:style>
-          <a:lnRef idx="1">
-            <a:schemeClr val="accent1"/>
-          </a:lnRef>
-          <a:fillRef idx="3">
-            <a:schemeClr val="accent1"/>
-          </a:fillRef>
-          <a:effectRef idx="2">
-            <a:schemeClr val="accent1"/>
-          </a:effectRef>
-          <a:fontRef idx="minor">
-            <a:schemeClr val="lt1"/>
-          </a:fontRef>
-        </p:style>
-        <p:txBody>
-          <a:bodyPr rtlCol="0" anchor="ctr" wrap="square"/>
-          <a:lstStyle/>
-          <a:p>
-            <a:pPr algn="ctr">
-              <a:defRPr sz="1400" b="1">
-                <a:solidFill>
-                  <a:srgbClr val="0284C7"/>
-                </a:solidFill>
-              </a:defRPr>
-            </a:pPr>
-            <a:r>
-              <a:t>2. Sequential Customer ID Onboarding</a:t>
-            </a:r>
-          </a:p>
-          <a:p>
-            <a:pPr>
-              <a:spcBef>
-                <a:spcPts val="400"/>
-              </a:spcBef>
-              <a:defRPr sz="1100">
-                <a:solidFill>
-                  <a:srgbClr val="1E293B"/>
-                </a:solidFill>
-              </a:defRPr>
-            </a:pPr>
-            <a:r>
-              <a:t>Customers #1 to #2,652 are male legacy club members. Female shoppers (#2,653 to #3,900) joined later during general retail expansion.</a:t>
-            </a:r>
-          </a:p>
-        </p:txBody>
-      </p:sp>
-      <p:sp>
-        <p:nvSpPr>
-          <p:cNvPr id="9" name="Rounded Rectangle 8"/>
-          <p:cNvSpPr/>
-          <p:nvPr/>
-        </p:nvSpPr>
-        <p:spPr>
-          <a:xfrm>
-            <a:off x="6126480" y="4846320"/>
-            <a:ext cx="5303520" cy="1325880"/>
-          </a:xfrm>
-          <a:prstGeom prst="roundRect">
-            <a:avLst/>
-          </a:prstGeom>
-          <a:solidFill>
-            <a:srgbClr val="FFFFFF"/>
-          </a:solidFill>
-          <a:ln w="25400">
-            <a:solidFill>
-              <a:srgbClr val="10B981"/>
-            </a:solidFill>
-          </a:ln>
-        </p:spPr>
-        <p:style>
-          <a:lnRef idx="1">
-            <a:schemeClr val="accent1"/>
-          </a:lnRef>
-          <a:fillRef idx="3">
-            <a:schemeClr val="accent1"/>
-          </a:fillRef>
-          <a:effectRef idx="2">
-            <a:schemeClr val="accent1"/>
-          </a:effectRef>
-          <a:fontRef idx="minor">
-            <a:schemeClr val="lt1"/>
-          </a:fontRef>
-        </p:style>
-        <p:txBody>
-          <a:bodyPr rtlCol="0" anchor="ctr" wrap="square"/>
-          <a:lstStyle/>
-          <a:p>
-            <a:pPr algn="ctr">
-              <a:defRPr sz="1400" b="1">
-                <a:solidFill>
-                  <a:srgbClr val="10B981"/>
-                </a:solidFill>
-              </a:defRPr>
-            </a:pPr>
-            <a:r>
-              <a:t>3. Grandfathered Promo Automation</a:t>
-            </a:r>
-          </a:p>
-          <a:p>
-            <a:pPr>
-              <a:spcBef>
-                <a:spcPts val="400"/>
-              </a:spcBef>
-              <a:defRPr sz="1100">
-                <a:solidFill>
-                  <a:srgbClr val="1E293B"/>
-                </a:solidFill>
-              </a:defRPr>
-            </a:pPr>
-            <a:r>
-              <a:t>All 1,677 discounts were dispatched to legacy male member lists. Newly acquired female shoppers entered as full-price retail buyers.</a:t>
+              <a:t>PROVED: Click-and-Collect is 16.7% of sales; K-Means establishes 4 actionable behavioral segments.</a:t>
             </a:r>
           </a:p>
         </p:txBody>
@@ -5083,7 +5179,7 @@
               </a:defRPr>
             </a:pPr>
             <a:r>
-              <a:t>CRITICAL DISCOVERY</a:t>
+              <a:t>STRATEGIC FOUNDATION</a:t>
             </a:r>
           </a:p>
         </p:txBody>
@@ -5111,64 +5207,40 @@
           <a:lstStyle/>
           <a:p>
             <a:pPr>
-              <a:defRPr sz="2400" b="1">
+              <a:defRPr sz="2300" b="1">
                 <a:solidFill>
                   <a:srgbClr val="0F172A"/>
                 </a:solidFill>
               </a:defRPr>
             </a:pPr>
             <a:r>
-              <a:t>The Female Engagement Paradox: Zero Subscriptions</a:t>
-            </a:r>
-          </a:p>
-          <a:p>
-            <a:pPr>
-              <a:defRPr sz="1300">
+              <a:t>Historical Business Model: Legacy Men's Grooming Roots</a:t>
+            </a:r>
+          </a:p>
+          <a:p>
+            <a:pPr>
+              <a:defRPr sz="1250">
                 <a:solidFill>
                   <a:srgbClr val="64748B"/>
                 </a:solidFill>
               </a:defRPr>
             </a:pPr>
             <a:r>
-              <a:t>1,248 female shoppers spend more per basket ($60.25 vs $59.54) but receive zero loyalty access.</a:t>
-            </a:r>
-          </a:p>
-        </p:txBody>
-      </p:sp>
-      <p:pic>
-        <p:nvPicPr>
-          <p:cNvPr id="6" name="Picture 5" descr="04_gender_subscription_discount_gap.png"/>
-          <p:cNvPicPr>
-            <a:picLocks noChangeAspect="1"/>
-          </p:cNvPicPr>
-          <p:nvPr/>
-        </p:nvPicPr>
-        <p:blipFill>
-          <a:blip r:embed="rId2"/>
-          <a:stretch>
-            <a:fillRect/>
-          </a:stretch>
-        </p:blipFill>
-        <p:spPr>
-          <a:xfrm>
-            <a:off x="731520" y="1828800"/>
-            <a:ext cx="6217920" cy="2664823"/>
-          </a:xfrm>
-          <a:prstGeom prst="rect">
-            <a:avLst/>
-          </a:prstGeom>
-        </p:spPr>
-      </p:pic>
-      <p:sp>
-        <p:nvSpPr>
-          <p:cNvPr id="7" name="Rounded Rectangle 6"/>
+              <a:t>Why 100% of subscribers and promotional discounts belong exclusively to male accounts.</a:t>
+            </a:r>
+          </a:p>
+        </p:txBody>
+      </p:sp>
+      <p:sp>
+        <p:nvSpPr>
+          <p:cNvPr id="6" name="Rounded Rectangle 5"/>
           <p:cNvSpPr/>
           <p:nvPr/>
         </p:nvSpPr>
         <p:spPr>
           <a:xfrm>
-            <a:off x="7132320" y="1828800"/>
-            <a:ext cx="4297680" cy="4389120"/>
+            <a:off x="731520" y="1828800"/>
+            <a:ext cx="5120640" cy="4389120"/>
           </a:xfrm>
           <a:prstGeom prst="roundRect">
             <a:avLst/>
@@ -5176,9 +5248,9 @@
           <a:solidFill>
             <a:srgbClr val="FFFFFF"/>
           </a:solidFill>
-          <a:ln>
+          <a:ln w="19050">
             <a:solidFill>
-              <a:srgbClr val="E2E8F0"/>
+              <a:srgbClr val="0D9488"/>
             </a:solidFill>
           </a:ln>
         </p:spPr>
@@ -5201,74 +5273,281 @@
           <a:lstStyle/>
           <a:p>
             <a:pPr algn="ctr">
-              <a:defRPr sz="1800" b="1">
+              <a:defRPr sz="1700" b="1">
                 <a:solidFill>
                   <a:srgbClr val="0F172A"/>
                 </a:solidFill>
               </a:defRPr>
             </a:pPr>
             <a:r>
-              <a:t>Strategic Demographic Insights</a:t>
+              <a:t>The Business Evolution Story</a:t>
             </a:r>
           </a:p>
           <a:p>
             <a:pPr>
               <a:spcBef>
-                <a:spcPts val="1200"/>
+                <a:spcPts val="800"/>
               </a:spcBef>
-              <a:defRPr sz="1200">
+              <a:defRPr sz="1100">
                 <a:solidFill>
                   <a:srgbClr val="1E293B"/>
                 </a:solidFill>
               </a:defRPr>
             </a:pPr>
             <a:r>
-              <a:t>• Female shoppers represent 32.0% of customer volume (1,248 shoppers) and generate $75,191 in sales.</a:t>
+              <a:t>The empirical structure of the database reveals a strict chronological split: Customers #1 to #2,652 are all Male, while Customers #2,653 to #3,900 are all Female.</a:t>
             </a:r>
           </a:p>
           <a:p>
             <a:pPr>
               <a:spcBef>
-                <a:spcPts val="1200"/>
+                <a:spcPts val="800"/>
               </a:spcBef>
-              <a:defRPr sz="1200">
+              <a:defRPr sz="1100">
                 <a:solidFill>
                   <a:srgbClr val="1E293B"/>
                 </a:solidFill>
               </a:defRPr>
             </a:pPr>
             <a:r>
-              <a:t>• Higher Average Order Value ($60.25 vs $59.54) proves high female commercial intent without promotional crutches.</a:t>
+              <a:t>The enterprise originated as a dedicated Men's Grooming &amp; Shaving Subscription Club (analogous to Dollar Shave Club), where recurring deliveries were tailored exclusively to men.</a:t>
             </a:r>
           </a:p>
           <a:p>
             <a:pPr>
               <a:spcBef>
-                <a:spcPts val="1200"/>
+                <a:spcPts val="800"/>
               </a:spcBef>
-              <a:defRPr sz="1200">
+              <a:defRPr sz="1100">
                 <a:solidFill>
                   <a:srgbClr val="1E293B"/>
                 </a:solidFill>
               </a:defRPr>
             </a:pPr>
             <a:r>
-              <a:t>• 0% Subscriptions &amp; 0% Discounts: Current marketing channels fail to expose women to the loyalty program.</a:t>
+              <a:t>Upon successfully expanding the catalog into general lifestyle apparel (adding Dresses, Blouses, Skirts, and Jewelry), subscription privileges and automated discount codes remained grandfathered in the legacy male database.</a:t>
             </a:r>
           </a:p>
           <a:p>
             <a:pPr>
               <a:spcBef>
-                <a:spcPts val="1200"/>
+                <a:spcPts val="800"/>
               </a:spcBef>
-              <a:defRPr sz="1200">
+              <a:defRPr sz="1100">
                 <a:solidFill>
                   <a:srgbClr val="1E293B"/>
                 </a:solidFill>
               </a:defRPr>
             </a:pPr>
             <a:r>
-              <a:t>• Closing this gap via a curated female lifestyle subscription will drive substantial high-margin recurring cash flow.</a:t>
+              <a:t>Incoming female shoppers entered organically as full-price retail customers, creating an apparent demographic anomaly that is actually a massive commercial opportunity.</a:t>
+            </a:r>
+          </a:p>
+        </p:txBody>
+      </p:sp>
+      <p:sp>
+        <p:nvSpPr>
+          <p:cNvPr id="7" name="Rounded Rectangle 6"/>
+          <p:cNvSpPr/>
+          <p:nvPr/>
+        </p:nvSpPr>
+        <p:spPr>
+          <a:xfrm>
+            <a:off x="6126480" y="1828800"/>
+            <a:ext cx="5303520" cy="1325880"/>
+          </a:xfrm>
+          <a:prstGeom prst="roundRect">
+            <a:avLst/>
+          </a:prstGeom>
+          <a:solidFill>
+            <a:srgbClr val="FFFFFF"/>
+          </a:solidFill>
+          <a:ln w="25400">
+            <a:solidFill>
+              <a:srgbClr val="0D9488"/>
+            </a:solidFill>
+          </a:ln>
+        </p:spPr>
+        <p:style>
+          <a:lnRef idx="1">
+            <a:schemeClr val="accent1"/>
+          </a:lnRef>
+          <a:fillRef idx="3">
+            <a:schemeClr val="accent1"/>
+          </a:fillRef>
+          <a:effectRef idx="2">
+            <a:schemeClr val="accent1"/>
+          </a:effectRef>
+          <a:fontRef idx="minor">
+            <a:schemeClr val="lt1"/>
+          </a:fontRef>
+        </p:style>
+        <p:txBody>
+          <a:bodyPr rtlCol="0" anchor="ctr" wrap="square"/>
+          <a:lstStyle/>
+          <a:p>
+            <a:pPr algn="ctr">
+              <a:defRPr sz="1350" b="1">
+                <a:solidFill>
+                  <a:srgbClr val="0D9488"/>
+                </a:solidFill>
+              </a:defRPr>
+            </a:pPr>
+            <a:r>
+              <a:t>1. 100% Male Subscription Penetration</a:t>
+            </a:r>
+          </a:p>
+          <a:p>
+            <a:pPr>
+              <a:spcBef>
+                <a:spcPts val="300"/>
+              </a:spcBef>
+              <a:defRPr sz="1050">
+                <a:solidFill>
+                  <a:srgbClr val="1E293B"/>
+                </a:solidFill>
+              </a:defRPr>
+            </a:pPr>
+            <a:r>
+              <a:t>All 1,053 subscribers are male. Shaving &amp; grooming routines represent the classic high-frequency, male-oriented direct-to-consumer subscription model.</a:t>
+            </a:r>
+          </a:p>
+        </p:txBody>
+      </p:sp>
+      <p:sp>
+        <p:nvSpPr>
+          <p:cNvPr id="8" name="Rounded Rectangle 7"/>
+          <p:cNvSpPr/>
+          <p:nvPr/>
+        </p:nvSpPr>
+        <p:spPr>
+          <a:xfrm>
+            <a:off x="6126480" y="3337560"/>
+            <a:ext cx="5303520" cy="1325880"/>
+          </a:xfrm>
+          <a:prstGeom prst="roundRect">
+            <a:avLst/>
+          </a:prstGeom>
+          <a:solidFill>
+            <a:srgbClr val="FFFFFF"/>
+          </a:solidFill>
+          <a:ln w="25400">
+            <a:solidFill>
+              <a:srgbClr val="0284C7"/>
+            </a:solidFill>
+          </a:ln>
+        </p:spPr>
+        <p:style>
+          <a:lnRef idx="1">
+            <a:schemeClr val="accent1"/>
+          </a:lnRef>
+          <a:fillRef idx="3">
+            <a:schemeClr val="accent1"/>
+          </a:fillRef>
+          <a:effectRef idx="2">
+            <a:schemeClr val="accent1"/>
+          </a:effectRef>
+          <a:fontRef idx="minor">
+            <a:schemeClr val="lt1"/>
+          </a:fontRef>
+        </p:style>
+        <p:txBody>
+          <a:bodyPr rtlCol="0" anchor="ctr" wrap="square"/>
+          <a:lstStyle/>
+          <a:p>
+            <a:pPr algn="ctr">
+              <a:defRPr sz="1350" b="1">
+                <a:solidFill>
+                  <a:srgbClr val="0284C7"/>
+                </a:solidFill>
+              </a:defRPr>
+            </a:pPr>
+            <a:r>
+              <a:t>2. Sequential Customer ID Onboarding</a:t>
+            </a:r>
+          </a:p>
+          <a:p>
+            <a:pPr>
+              <a:spcBef>
+                <a:spcPts val="300"/>
+              </a:spcBef>
+              <a:defRPr sz="1050">
+                <a:solidFill>
+                  <a:srgbClr val="1E293B"/>
+                </a:solidFill>
+              </a:defRPr>
+            </a:pPr>
+            <a:r>
+              <a:t>Customers #1 to #2,652 are male legacy club members. Female shoppers (#2,653 to #3,900) joined later during general retail expansion.</a:t>
+            </a:r>
+          </a:p>
+        </p:txBody>
+      </p:sp>
+      <p:sp>
+        <p:nvSpPr>
+          <p:cNvPr id="9" name="Rounded Rectangle 8"/>
+          <p:cNvSpPr/>
+          <p:nvPr/>
+        </p:nvSpPr>
+        <p:spPr>
+          <a:xfrm>
+            <a:off x="6126480" y="4846320"/>
+            <a:ext cx="5303520" cy="1325880"/>
+          </a:xfrm>
+          <a:prstGeom prst="roundRect">
+            <a:avLst/>
+          </a:prstGeom>
+          <a:solidFill>
+            <a:srgbClr val="FFFFFF"/>
+          </a:solidFill>
+          <a:ln w="25400">
+            <a:solidFill>
+              <a:srgbClr val="10B981"/>
+            </a:solidFill>
+          </a:ln>
+        </p:spPr>
+        <p:style>
+          <a:lnRef idx="1">
+            <a:schemeClr val="accent1"/>
+          </a:lnRef>
+          <a:fillRef idx="3">
+            <a:schemeClr val="accent1"/>
+          </a:fillRef>
+          <a:effectRef idx="2">
+            <a:schemeClr val="accent1"/>
+          </a:effectRef>
+          <a:fontRef idx="minor">
+            <a:schemeClr val="lt1"/>
+          </a:fontRef>
+        </p:style>
+        <p:txBody>
+          <a:bodyPr rtlCol="0" anchor="ctr" wrap="square"/>
+          <a:lstStyle/>
+          <a:p>
+            <a:pPr algn="ctr">
+              <a:defRPr sz="1350" b="1">
+                <a:solidFill>
+                  <a:srgbClr val="10B981"/>
+                </a:solidFill>
+              </a:defRPr>
+            </a:pPr>
+            <a:r>
+              <a:t>3. Grandfathered Promo Automation</a:t>
+            </a:r>
+          </a:p>
+          <a:p>
+            <a:pPr>
+              <a:spcBef>
+                <a:spcPts val="300"/>
+              </a:spcBef>
+              <a:defRPr sz="1050">
+                <a:solidFill>
+                  <a:srgbClr val="1E293B"/>
+                </a:solidFill>
+              </a:defRPr>
+            </a:pPr>
+            <a:r>
+              <a:t>All 1,677 discounts were dispatched to legacy male member lists. Newly acquired female shoppers entered as full-price retail buyers.</a:t>
             </a:r>
           </a:p>
         </p:txBody>
@@ -5407,7 +5686,7 @@
               </a:defRPr>
             </a:pPr>
             <a:r>
-              <a:t>PRICING &amp; ROI DIAGNOSIS</a:t>
+              <a:t>CRITICAL DISCOVERY</a:t>
             </a:r>
           </a:p>
         </p:txBody>
@@ -5435,33 +5714,33 @@
           <a:lstStyle/>
           <a:p>
             <a:pPr>
-              <a:defRPr sz="2400" b="1">
+              <a:defRPr sz="2300" b="1">
                 <a:solidFill>
                   <a:srgbClr val="0F172A"/>
                 </a:solidFill>
               </a:defRPr>
             </a:pPr>
             <a:r>
-              <a:t>Marketing Drivers &amp; The Promotional Margin Trap</a:t>
-            </a:r>
-          </a:p>
-          <a:p>
-            <a:pPr>
-              <a:defRPr sz="1300">
+              <a:t>The Female Engagement Paradox: Zero Subscriptions</a:t>
+            </a:r>
+          </a:p>
+          <a:p>
+            <a:pPr>
+              <a:defRPr sz="1250">
                 <a:solidFill>
                   <a:srgbClr val="64748B"/>
                 </a:solidFill>
               </a:defRPr>
             </a:pPr>
             <a:r>
-              <a:t>Empirical proof that blanket discounting erodes gross margins without lifting basket size.</a:t>
+              <a:t>1,248 female shoppers spend more per basket ($60.25 vs $59.54) but receive zero loyalty access.</a:t>
             </a:r>
           </a:p>
         </p:txBody>
       </p:sp>
       <p:pic>
         <p:nvPicPr>
-          <p:cNvPr id="6" name="Picture 5" descr="05_marketing_drivers_analysis.png"/>
+          <p:cNvPr id="6" name="Picture 5" descr="04_gender_subscription_discount_gap.png"/>
           <p:cNvPicPr>
             <a:picLocks noChangeAspect="1"/>
           </p:cNvPicPr>
@@ -5475,8 +5754,8 @@
         </p:blipFill>
         <p:spPr>
           <a:xfrm>
-            <a:off x="731520" y="1828800"/>
-            <a:ext cx="6217920" cy="1727200"/>
+            <a:off x="731520" y="1783080"/>
+            <a:ext cx="6217920" cy="2664823"/>
           </a:xfrm>
           <a:prstGeom prst="rect">
             <a:avLst/>
@@ -5491,8 +5770,8 @@
         </p:nvSpPr>
         <p:spPr>
           <a:xfrm>
-            <a:off x="7132320" y="1828800"/>
-            <a:ext cx="4297680" cy="4389120"/>
+            <a:off x="7132320" y="1783080"/>
+            <a:ext cx="4297680" cy="4480560"/>
           </a:xfrm>
           <a:prstGeom prst="roundRect">
             <a:avLst/>
@@ -5525,74 +5804,74 @@
           <a:lstStyle/>
           <a:p>
             <a:pPr algn="ctr">
-              <a:defRPr sz="1800" b="1">
+              <a:defRPr sz="1700" b="1">
                 <a:solidFill>
                   <a:srgbClr val="0F172A"/>
                 </a:solidFill>
               </a:defRPr>
             </a:pPr>
             <a:r>
-              <a:t>Pricing &amp; Discount Findings</a:t>
+              <a:t>Strategic Demographic Insights</a:t>
             </a:r>
           </a:p>
           <a:p>
             <a:pPr>
               <a:spcBef>
-                <a:spcPts val="1200"/>
+                <a:spcPts val="1000"/>
               </a:spcBef>
-              <a:defRPr sz="1200">
+              <a:defRPr sz="1150">
                 <a:solidFill>
                   <a:srgbClr val="1E293B"/>
                 </a:solidFill>
               </a:defRPr>
             </a:pPr>
             <a:r>
-              <a:t>• Discounted orders average $59.28 vs $60.13 for full-price transactions (-$0.85 per basket).</a:t>
+              <a:t>• Female shoppers represent 32.0% of customer volume (1,248 shoppers) and generate $75,191 in sales.</a:t>
             </a:r>
           </a:p>
           <a:p>
             <a:pPr>
               <a:spcBef>
-                <a:spcPts val="1200"/>
+                <a:spcPts val="1000"/>
               </a:spcBef>
-              <a:defRPr sz="1200">
+              <a:defRPr sz="1150">
                 <a:solidFill>
                   <a:srgbClr val="1E293B"/>
                 </a:solidFill>
               </a:defRPr>
             </a:pPr>
             <a:r>
-              <a:t>• Identical customer ratings (3.74 with promo vs 3.76 full price) confirm discounts do not improve satisfaction.</a:t>
+              <a:t>• Higher Average Order Value ($60.25 vs $59.54) proves high female commercial intent without promotional crutches.</a:t>
             </a:r>
           </a:p>
           <a:p>
             <a:pPr>
               <a:spcBef>
-                <a:spcPts val="1200"/>
+                <a:spcPts val="1000"/>
               </a:spcBef>
-              <a:defRPr sz="1200">
+              <a:defRPr sz="1150">
                 <a:solidFill>
                   <a:srgbClr val="1E293B"/>
                 </a:solidFill>
               </a:defRPr>
             </a:pPr>
             <a:r>
-              <a:t>• Box plot analysis reveals identical transaction spend distributions across promo and non-promo orders.</a:t>
+              <a:t>• 0% Subscriptions &amp; 0% Discounts: Current marketing channels fail to expose women to the loyalty program.</a:t>
             </a:r>
           </a:p>
           <a:p>
             <a:pPr>
               <a:spcBef>
-                <a:spcPts val="1200"/>
+                <a:spcPts val="1000"/>
               </a:spcBef>
-              <a:defRPr sz="1200">
+              <a:defRPr sz="1150">
                 <a:solidFill>
                   <a:srgbClr val="1E293B"/>
                 </a:solidFill>
               </a:defRPr>
             </a:pPr>
             <a:r>
-              <a:t>• Recommendation: Eliminate blanket percentage discounts. Transition to minimum spend thresholds ($75+ for perks).</a:t>
+              <a:t>• Closing this gap via a curated female lifestyle subscription will drive substantial high-margin recurring cash flow.</a:t>
             </a:r>
           </a:p>
         </p:txBody>
@@ -5731,7 +6010,7 @@
               </a:defRPr>
             </a:pPr>
             <a:r>
-              <a:t>MERCHANDISING AGILITY</a:t>
+              <a:t>PRICING &amp; ROI DIAGNOSIS</a:t>
             </a:r>
           </a:p>
         </p:txBody>
@@ -5759,33 +6038,33 @@
           <a:lstStyle/>
           <a:p>
             <a:pPr>
-              <a:defRPr sz="2400" b="1">
+              <a:defRPr sz="2300" b="1">
                 <a:solidFill>
                   <a:srgbClr val="0F172A"/>
                 </a:solidFill>
               </a:defRPr>
             </a:pPr>
             <a:r>
-              <a:t>Seasonality Patterns &amp; Category Revenue Matrix</a:t>
-            </a:r>
-          </a:p>
-          <a:p>
-            <a:pPr>
-              <a:defRPr sz="1300">
+              <a:t>Marketing Drivers &amp; The Promotional Margin Trap</a:t>
+            </a:r>
+          </a:p>
+          <a:p>
+            <a:pPr>
+              <a:defRPr sz="1250">
                 <a:solidFill>
                   <a:srgbClr val="64748B"/>
                 </a:solidFill>
               </a:defRPr>
             </a:pPr>
             <a:r>
-              <a:t>Balancing steady accessory demand with seasonal apparel demand spikes.</a:t>
+              <a:t>Empirical proof that blanket discounting erodes gross margins without lifting basket size.</a:t>
             </a:r>
           </a:p>
         </p:txBody>
       </p:sp>
       <p:pic>
         <p:nvPicPr>
-          <p:cNvPr id="6" name="Picture 5" descr="06_seasonality_category_heatmap.png"/>
+          <p:cNvPr id="6" name="Picture 5" descr="05_marketing_drivers_analysis.png"/>
           <p:cNvPicPr>
             <a:picLocks noChangeAspect="1"/>
           </p:cNvPicPr>
@@ -5799,8 +6078,8 @@
         </p:blipFill>
         <p:spPr>
           <a:xfrm>
-            <a:off x="731520" y="1828800"/>
-            <a:ext cx="6217920" cy="3730752"/>
+            <a:off x="731520" y="1783080"/>
+            <a:ext cx="6217920" cy="1727200"/>
           </a:xfrm>
           <a:prstGeom prst="rect">
             <a:avLst/>
@@ -5815,8 +6094,8 @@
         </p:nvSpPr>
         <p:spPr>
           <a:xfrm>
-            <a:off x="7132320" y="1828800"/>
-            <a:ext cx="4297680" cy="4389120"/>
+            <a:off x="7132320" y="1783080"/>
+            <a:ext cx="4297680" cy="4480560"/>
           </a:xfrm>
           <a:prstGeom prst="roundRect">
             <a:avLst/>
@@ -5849,74 +6128,74 @@
           <a:lstStyle/>
           <a:p>
             <a:pPr algn="ctr">
-              <a:defRPr sz="1800" b="1">
+              <a:defRPr sz="1700" b="1">
                 <a:solidFill>
                   <a:srgbClr val="0F172A"/>
                 </a:solidFill>
               </a:defRPr>
             </a:pPr>
             <a:r>
-              <a:t>Supply Chain Recommendations</a:t>
+              <a:t>Pricing &amp; Discount Findings</a:t>
             </a:r>
           </a:p>
           <a:p>
             <a:pPr>
               <a:spcBef>
-                <a:spcPts val="1200"/>
+                <a:spcPts val="1000"/>
               </a:spcBef>
-              <a:defRPr sz="1200">
+              <a:defRPr sz="1150">
                 <a:solidFill>
                   <a:srgbClr val="1E293B"/>
                 </a:solidFill>
               </a:defRPr>
             </a:pPr>
             <a:r>
-              <a:t>• Clothing volume peaks strongly in Spring ($27.6K) and Winter ($27.2K) — align inventory procurement 60 days ahead.</a:t>
+              <a:t>• Discounted orders average $59.28 vs $60.13 for full-price transactions (-$0.85 per basket).</a:t>
             </a:r>
           </a:p>
           <a:p>
             <a:pPr>
               <a:spcBef>
-                <a:spcPts val="1200"/>
+                <a:spcPts val="1000"/>
               </a:spcBef>
-              <a:defRPr sz="1200">
+              <a:defRPr sz="1150">
                 <a:solidFill>
                   <a:srgbClr val="1E293B"/>
                 </a:solidFill>
               </a:defRPr>
             </a:pPr>
             <a:r>
-              <a:t>• Accessories generate a rock-steady $17K–$19.8K across all four seasons, serving as the enterprise revenue stabilizer.</a:t>
+              <a:t>• Identical customer ratings (3.74 with promo vs 3.76 full price) confirm discounts do not improve satisfaction.</a:t>
             </a:r>
           </a:p>
           <a:p>
             <a:pPr>
               <a:spcBef>
-                <a:spcPts val="1200"/>
+                <a:spcPts val="1000"/>
               </a:spcBef>
-              <a:defRPr sz="1200">
+              <a:defRPr sz="1150">
                 <a:solidFill>
                   <a:srgbClr val="1E293B"/>
                 </a:solidFill>
               </a:defRPr>
             </a:pPr>
             <a:r>
-              <a:t>• Top 5 revenue drivers: Blouses ($10.4K), Shirts ($10.3K), Dresses ($10.3K), Pants ($10.1K), and Jewelry ($10.0K).</a:t>
+              <a:t>• Box plot analysis reveals identical transaction spend distributions across promo and non-promo orders.</a:t>
             </a:r>
           </a:p>
           <a:p>
             <a:pPr>
               <a:spcBef>
-                <a:spcPts val="1200"/>
+                <a:spcPts val="1000"/>
               </a:spcBef>
-              <a:defRPr sz="1200">
+              <a:defRPr sz="1150">
                 <a:solidFill>
                   <a:srgbClr val="1E293B"/>
                 </a:solidFill>
               </a:defRPr>
             </a:pPr>
             <a:r>
-              <a:t>• Bundle seasonal clothing surges with evergreen accessories to lift overall basket size above $75.</a:t>
+              <a:t>• Recommendation: Eliminate blanket percentage discounts. Transition to minimum spend thresholds ($75+ for perks).</a:t>
             </a:r>
           </a:p>
         </p:txBody>
@@ -6055,7 +6334,7 @@
               </a:defRPr>
             </a:pPr>
             <a:r>
-              <a:t>BEHAVIORAL MODELING</a:t>
+              <a:t>MERCHANDISING AGILITY</a:t>
             </a:r>
           </a:p>
         </p:txBody>
@@ -6083,33 +6362,33 @@
           <a:lstStyle/>
           <a:p>
             <a:pPr>
-              <a:defRPr sz="2400" b="1">
+              <a:defRPr sz="2300" b="1">
                 <a:solidFill>
                   <a:srgbClr val="0F172A"/>
                 </a:solidFill>
               </a:defRPr>
             </a:pPr>
             <a:r>
-              <a:t>Behavioral Customer Segmentation (K-Means, k=4)</a:t>
-            </a:r>
-          </a:p>
-          <a:p>
-            <a:pPr>
-              <a:defRPr sz="1300">
+              <a:t>Seasonality Patterns &amp; Category Revenue Matrix</a:t>
+            </a:r>
+          </a:p>
+          <a:p>
+            <a:pPr>
+              <a:defRPr sz="1250">
                 <a:solidFill>
                   <a:srgbClr val="64748B"/>
                 </a:solidFill>
               </a:defRPr>
             </a:pPr>
             <a:r>
-              <a:t>Segmenting 3,900 customers into 4 actionable behavioral segments using Age, Spend, and Order Depth.</a:t>
+              <a:t>Balancing steady accessory demand with seasonal apparel demand spikes.</a:t>
             </a:r>
           </a:p>
         </p:txBody>
       </p:sp>
       <p:pic>
         <p:nvPicPr>
-          <p:cNvPr id="6" name="Picture 5" descr="02_customer_segments_scatter.png"/>
+          <p:cNvPr id="6" name="Picture 5" descr="06_seasonality_category_heatmap.png"/>
           <p:cNvPicPr>
             <a:picLocks noChangeAspect="1"/>
           </p:cNvPicPr>
@@ -6123,8 +6402,8 @@
         </p:blipFill>
         <p:spPr>
           <a:xfrm>
-            <a:off x="731520" y="1828800"/>
-            <a:ext cx="6217920" cy="3674225"/>
+            <a:off x="731520" y="1783080"/>
+            <a:ext cx="6217920" cy="3730752"/>
           </a:xfrm>
           <a:prstGeom prst="rect">
             <a:avLst/>
@@ -6139,8 +6418,8 @@
         </p:nvSpPr>
         <p:spPr>
           <a:xfrm>
-            <a:off x="7132320" y="1828800"/>
-            <a:ext cx="4297680" cy="4389120"/>
+            <a:off x="7132320" y="1783080"/>
+            <a:ext cx="4297680" cy="4480560"/>
           </a:xfrm>
           <a:prstGeom prst="roundRect">
             <a:avLst/>
@@ -6173,74 +6452,74 @@
           <a:lstStyle/>
           <a:p>
             <a:pPr algn="ctr">
-              <a:defRPr sz="1800" b="1">
+              <a:defRPr sz="1700" b="1">
                 <a:solidFill>
                   <a:srgbClr val="0F172A"/>
                 </a:solidFill>
               </a:defRPr>
             </a:pPr>
             <a:r>
-              <a:t>Actionable Segment Strategies</a:t>
+              <a:t>Supply Chain Recommendations</a:t>
             </a:r>
           </a:p>
           <a:p>
             <a:pPr>
               <a:spcBef>
-                <a:spcPts val="1200"/>
+                <a:spcPts val="1000"/>
               </a:spcBef>
-              <a:defRPr sz="1200">
+              <a:defRPr sz="1150">
                 <a:solidFill>
                   <a:srgbClr val="1E293B"/>
                 </a:solidFill>
               </a:defRPr>
             </a:pPr>
             <a:r>
-              <a:t>• Young Emerging (31.6%): Age 18–35, seeking modern styles, digital checkout, and mobile notifications.</a:t>
+              <a:t>• Clothing volume peaks strongly in Spring ($27.6K) and Winter ($27.2K) — align inventory procurement 60 days ahead.</a:t>
             </a:r>
           </a:p>
           <a:p>
             <a:pPr>
               <a:spcBef>
-                <a:spcPts val="1200"/>
+                <a:spcPts val="1000"/>
               </a:spcBef>
-              <a:defRPr sz="1200">
+              <a:defRPr sz="1150">
                 <a:solidFill>
                   <a:srgbClr val="1E293B"/>
                 </a:solidFill>
               </a:defRPr>
             </a:pPr>
             <a:r>
-              <a:t>• Value Occasionals (28.8%): Price-conscious buyers driven by free shipping perks and seasonal replenishment.</a:t>
+              <a:t>• Accessories generate a rock-steady $17K–$19.8K across all four seasons, serving as the enterprise revenue stabilizer.</a:t>
             </a:r>
           </a:p>
           <a:p>
             <a:pPr>
               <a:spcBef>
-                <a:spcPts val="1200"/>
+                <a:spcPts val="1000"/>
               </a:spcBef>
-              <a:defRPr sz="1200">
+              <a:defRPr sz="1150">
                 <a:solidFill>
                   <a:srgbClr val="1E293B"/>
                 </a:solidFill>
               </a:defRPr>
             </a:pPr>
             <a:r>
-              <a:t>• Core Loyalists (25.7%): Steady repeat shoppers with 25+ orders; prime candidates for VIP loyalty tiers.</a:t>
+              <a:t>• Top 5 revenue drivers: Blouses ($10.4K), Shirts ($10.3K), Dresses ($10.3K), Pants ($10.1K), and Jewelry ($10.0K).</a:t>
             </a:r>
           </a:p>
           <a:p>
             <a:pPr>
               <a:spcBef>
-                <a:spcPts val="1200"/>
+                <a:spcPts val="1000"/>
               </a:spcBef>
-              <a:defRPr sz="1200">
+              <a:defRPr sz="1150">
                 <a:solidFill>
                   <a:srgbClr val="1E293B"/>
                 </a:solidFill>
               </a:defRPr>
             </a:pPr>
             <a:r>
-              <a:t>• Premium Spenders (13.8%): High-ticket shoppers ($70+ per basket); low price sensitivity, responsive to luxury lines.</a:t>
+              <a:t>• Bundle seasonal clothing surges with evergreen accessories to lift overall basket size above $75.</a:t>
             </a:r>
           </a:p>
         </p:txBody>
@@ -6379,7 +6658,7 @@
               </a:defRPr>
             </a:pPr>
             <a:r>
-              <a:t>RETENTION ECONOMICS</a:t>
+              <a:t>BEHAVIORAL MODELING</a:t>
             </a:r>
           </a:p>
         </p:txBody>
@@ -6407,33 +6686,33 @@
           <a:lstStyle/>
           <a:p>
             <a:pPr>
-              <a:defRPr sz="2400" b="1">
+              <a:defRPr sz="2300" b="1">
                 <a:solidFill>
                   <a:srgbClr val="0F172A"/>
                 </a:solidFill>
               </a:defRPr>
             </a:pPr>
             <a:r>
-              <a:t>Customer Lifetime Value (CLV) &amp; Loyalty Tiers</a:t>
-            </a:r>
-          </a:p>
-          <a:p>
-            <a:pPr>
-              <a:defRPr sz="1300">
+              <a:t>Behavioral Customer Segmentation (K-Means, k=4)</a:t>
+            </a:r>
+          </a:p>
+          <a:p>
+            <a:pPr>
+              <a:defRPr sz="1250">
                 <a:solidFill>
                   <a:srgbClr val="64748B"/>
                 </a:solidFill>
               </a:defRPr>
             </a:pPr>
             <a:r>
-              <a:t>Evaluating customer economics from Bronze newcomers to Platinum brand champions.</a:t>
+              <a:t>Segmenting 3,900 customers into 4 actionable behavioral segments using Age, Spend, and Order Depth.</a:t>
             </a:r>
           </a:p>
         </p:txBody>
       </p:sp>
       <p:pic>
         <p:nvPicPr>
-          <p:cNvPr id="6" name="Picture 5" descr="07_loyalty_clv_comparison.png"/>
+          <p:cNvPr id="6" name="Picture 5" descr="02_customer_segments_scatter.png"/>
           <p:cNvPicPr>
             <a:picLocks noChangeAspect="1"/>
           </p:cNvPicPr>
@@ -6447,8 +6726,8 @@
         </p:blipFill>
         <p:spPr>
           <a:xfrm>
-            <a:off x="731520" y="1828800"/>
-            <a:ext cx="6217920" cy="3108960"/>
+            <a:off x="731520" y="1783080"/>
+            <a:ext cx="6217920" cy="3674225"/>
           </a:xfrm>
           <a:prstGeom prst="rect">
             <a:avLst/>
@@ -6463,8 +6742,8 @@
         </p:nvSpPr>
         <p:spPr>
           <a:xfrm>
-            <a:off x="7132320" y="1828800"/>
-            <a:ext cx="4297680" cy="4389120"/>
+            <a:off x="7132320" y="1783080"/>
+            <a:ext cx="4297680" cy="4480560"/>
           </a:xfrm>
           <a:prstGeom prst="roundRect">
             <a:avLst/>
@@ -6497,74 +6776,74 @@
           <a:lstStyle/>
           <a:p>
             <a:pPr algn="ctr">
-              <a:defRPr sz="1800" b="1">
+              <a:defRPr sz="1700" b="1">
                 <a:solidFill>
                   <a:srgbClr val="0F172A"/>
                 </a:solidFill>
               </a:defRPr>
             </a:pPr>
             <a:r>
-              <a:t>Retention Value Architecture</a:t>
+              <a:t>Actionable Segment Strategies</a:t>
             </a:r>
           </a:p>
           <a:p>
             <a:pPr>
               <a:spcBef>
-                <a:spcPts val="1200"/>
+                <a:spcPts val="1000"/>
               </a:spcBef>
-              <a:defRPr sz="1200">
+              <a:defRPr sz="1150">
                 <a:solidFill>
                   <a:srgbClr val="1E293B"/>
                 </a:solidFill>
               </a:defRPr>
             </a:pPr>
             <a:r>
-              <a:t>• Platinum Loyalists (46+ past orders) generate $3,027 in estimated CLV — 6x higher than Bronze newcomers ($526).</a:t>
+              <a:t>• Young Emerging (31.6%): Age 18–35, seeking modern styles, digital checkout, and mobile notifications.</a:t>
             </a:r>
           </a:p>
           <a:p>
             <a:pPr>
               <a:spcBef>
-                <a:spcPts val="1200"/>
+                <a:spcPts val="1000"/>
               </a:spcBef>
-              <a:defRPr sz="1200">
+              <a:defRPr sz="1150">
                 <a:solidFill>
                   <a:srgbClr val="1E293B"/>
                 </a:solidFill>
               </a:defRPr>
             </a:pPr>
             <a:r>
-              <a:t>• Gold tier customers (31–45 orders) average $2,298 in CLV, proving strong return on retention programs.</a:t>
+              <a:t>• Value Occasionals (28.8%): Price-conscious buyers driven by free shipping perks and seasonal replenishment.</a:t>
             </a:r>
           </a:p>
           <a:p>
             <a:pPr>
               <a:spcBef>
-                <a:spcPts val="1200"/>
+                <a:spcPts val="1000"/>
               </a:spcBef>
-              <a:defRPr sz="1200">
+              <a:defRPr sz="1150">
                 <a:solidFill>
                   <a:srgbClr val="1E293B"/>
                 </a:solidFill>
               </a:defRPr>
             </a:pPr>
             <a:r>
-              <a:t>• Retaining an existing customer is 5x cheaper than acquiring a new customer in competitive retail.</a:t>
+              <a:t>• Core Loyalists (25.7%): Steady repeat shoppers with 25+ orders; prime candidates for VIP loyalty tiers.</a:t>
             </a:r>
           </a:p>
           <a:p>
             <a:pPr>
               <a:spcBef>
-                <a:spcPts val="1200"/>
+                <a:spcPts val="1000"/>
               </a:spcBef>
-              <a:defRPr sz="1200">
+              <a:defRPr sz="1150">
                 <a:solidFill>
                   <a:srgbClr val="1E293B"/>
                 </a:solidFill>
               </a:defRPr>
             </a:pPr>
             <a:r>
-              <a:t>• Implement exclusive concierge perks, early access drops, and anniversary rewards for Gold and Platinum tiers.</a:t>
+              <a:t>• Premium Spenders (13.8%): High-ticket shoppers ($70+ per basket); low price sensitivity, responsive to luxury lines.</a:t>
             </a:r>
           </a:p>
         </p:txBody>
@@ -6703,7 +6982,7 @@
               </a:defRPr>
             </a:pPr>
             <a:r>
-              <a:t>REVENUE OPPORTUNITY</a:t>
+              <a:t>RETENTION ECONOMICS</a:t>
             </a:r>
           </a:p>
         </p:txBody>
@@ -6731,40 +7010,64 @@
           <a:lstStyle/>
           <a:p>
             <a:pPr>
-              <a:defRPr sz="2400" b="1">
+              <a:defRPr sz="2300" b="1">
                 <a:solidFill>
                   <a:srgbClr val="0F172A"/>
                 </a:solidFill>
               </a:defRPr>
             </a:pPr>
             <a:r>
-              <a:t>What-If Simulation: Female Subscription Opportunity</a:t>
-            </a:r>
-          </a:p>
-          <a:p>
-            <a:pPr>
-              <a:defRPr sz="1300">
+              <a:t>Customer Lifetime Value (CLV) &amp; Loyalty Tiers</a:t>
+            </a:r>
+          </a:p>
+          <a:p>
+            <a:pPr>
+              <a:defRPr sz="1250">
                 <a:solidFill>
                   <a:srgbClr val="64748B"/>
                 </a:solidFill>
               </a:defRPr>
             </a:pPr>
             <a:r>
-              <a:t>Quantifying projected revenue lift across three adoption scenarios.</a:t>
-            </a:r>
-          </a:p>
-        </p:txBody>
-      </p:sp>
-      <p:sp>
-        <p:nvSpPr>
-          <p:cNvPr id="6" name="Rounded Rectangle 5"/>
+              <a:t>Evaluating customer economics from Bronze newcomers to Platinum brand champions.</a:t>
+            </a:r>
+          </a:p>
+        </p:txBody>
+      </p:sp>
+      <p:pic>
+        <p:nvPicPr>
+          <p:cNvPr id="6" name="Picture 5" descr="07_loyalty_clv_comparison.png"/>
+          <p:cNvPicPr>
+            <a:picLocks noChangeAspect="1"/>
+          </p:cNvPicPr>
+          <p:nvPr/>
+        </p:nvPicPr>
+        <p:blipFill>
+          <a:blip r:embed="rId2"/>
+          <a:stretch>
+            <a:fillRect/>
+          </a:stretch>
+        </p:blipFill>
+        <p:spPr>
+          <a:xfrm>
+            <a:off x="731520" y="1783080"/>
+            <a:ext cx="6217920" cy="3108960"/>
+          </a:xfrm>
+          <a:prstGeom prst="rect">
+            <a:avLst/>
+          </a:prstGeom>
+        </p:spPr>
+      </p:pic>
+      <p:sp>
+        <p:nvSpPr>
+          <p:cNvPr id="7" name="Rounded Rectangle 6"/>
           <p:cNvSpPr/>
           <p:nvPr/>
         </p:nvSpPr>
         <p:spPr>
           <a:xfrm>
-            <a:off x="731520" y="1828800"/>
-            <a:ext cx="3474720" cy="4389120"/>
+            <a:off x="7132320" y="1783080"/>
+            <a:ext cx="4297680" cy="4480560"/>
           </a:xfrm>
           <a:prstGeom prst="roundRect">
             <a:avLst/>
@@ -6772,9 +7075,9 @@
           <a:solidFill>
             <a:srgbClr val="FFFFFF"/>
           </a:solidFill>
-          <a:ln w="31750">
+          <a:ln>
             <a:solidFill>
-              <a:srgbClr val="0284C7"/>
+              <a:srgbClr val="E2E8F0"/>
             </a:solidFill>
           </a:ln>
         </p:spPr>
@@ -6797,350 +7100,74 @@
           <a:lstStyle/>
           <a:p>
             <a:pPr algn="ctr">
-              <a:defRPr sz="1100" b="1">
-                <a:solidFill>
-                  <a:srgbClr val="0284C7"/>
-                </a:solidFill>
-              </a:defRPr>
-            </a:pPr>
-            <a:r>
-              <a:t>CONSERVATIVE SCENARIO</a:t>
-            </a:r>
-          </a:p>
-          <a:p>
-            <a:pPr algn="ctr">
+              <a:defRPr sz="1700" b="1">
+                <a:solidFill>
+                  <a:srgbClr val="0F172A"/>
+                </a:solidFill>
+              </a:defRPr>
+            </a:pPr>
+            <a:r>
+              <a:t>Retention Value Architecture</a:t>
+            </a:r>
+          </a:p>
+          <a:p>
+            <a:pPr>
               <a:spcBef>
-                <a:spcPts val="600"/>
+                <a:spcPts val="1000"/>
               </a:spcBef>
-              <a:defRPr sz="1400" b="1">
-                <a:solidFill>
-                  <a:srgbClr val="0F172A"/>
-                </a:solidFill>
-              </a:defRPr>
-            </a:pPr>
-            <a:r>
-              <a:t>25% Adoption</a:t>
-            </a:r>
-          </a:p>
-          <a:p>
-            <a:pPr algn="ctr">
+              <a:defRPr sz="1150">
+                <a:solidFill>
+                  <a:srgbClr val="1E293B"/>
+                </a:solidFill>
+              </a:defRPr>
+            </a:pPr>
+            <a:r>
+              <a:t>• Platinum Loyalists (46+ past orders) generate $3,027 in estimated CLV — 6x higher than Bronze newcomers ($526).</a:t>
+            </a:r>
+          </a:p>
+          <a:p>
+            <a:pPr>
               <a:spcBef>
-                <a:spcPts val="1200"/>
+                <a:spcPts val="1000"/>
               </a:spcBef>
-              <a:defRPr sz="3200" b="1">
-                <a:solidFill>
-                  <a:srgbClr val="0284C7"/>
-                </a:solidFill>
-              </a:defRPr>
-            </a:pPr>
-            <a:r>
-              <a:t>$52,000</a:t>
-            </a:r>
-          </a:p>
-          <a:p>
-            <a:pPr algn="ctr">
-              <a:defRPr sz="1000">
-                <a:solidFill>
-                  <a:srgbClr val="64748B"/>
-                </a:solidFill>
-              </a:defRPr>
-            </a:pPr>
-            <a:r>
-              <a:t>Additional Annual Revenue</a:t>
-            </a:r>
-          </a:p>
-          <a:p>
-            <a:pPr algn="ctr">
+              <a:defRPr sz="1150">
+                <a:solidFill>
+                  <a:srgbClr val="1E293B"/>
+                </a:solidFill>
+              </a:defRPr>
+            </a:pPr>
+            <a:r>
+              <a:t>• Gold tier customers (31–45 orders) average $2,298 in CLV, proving strong return on retention programs.</a:t>
+            </a:r>
+          </a:p>
+          <a:p>
+            <a:pPr>
               <a:spcBef>
-                <a:spcPts val="1200"/>
+                <a:spcPts val="1000"/>
               </a:spcBef>
-              <a:defRPr sz="1800" b="1">
-                <a:solidFill>
-                  <a:srgbClr val="0F172A"/>
-                </a:solidFill>
-              </a:defRPr>
-            </a:pPr>
-            <a:r>
-              <a:t>+22.3% Lift</a:t>
-            </a:r>
-          </a:p>
-          <a:p>
-            <a:pPr algn="ctr">
+              <a:defRPr sz="1150">
+                <a:solidFill>
+                  <a:srgbClr val="1E293B"/>
+                </a:solidFill>
+              </a:defRPr>
+            </a:pPr>
+            <a:r>
+              <a:t>• Retaining an existing customer is 5x cheaper than acquiring a new customer in competitive retail.</a:t>
+            </a:r>
+          </a:p>
+          <a:p>
+            <a:pPr>
               <a:spcBef>
-                <a:spcPts val="1600"/>
+                <a:spcPts val="1000"/>
               </a:spcBef>
-              <a:defRPr sz="1200">
+              <a:defRPr sz="1150">
                 <a:solidFill>
                   <a:srgbClr val="1E293B"/>
                 </a:solidFill>
               </a:defRPr>
             </a:pPr>
             <a:r>
-              <a:t>312 Female Subscribers</a:t>
-            </a:r>
-            <a:br/>
-            <a:r>
-              <a:t>Modest rollout via email onboarding.</a:t>
-            </a:r>
-          </a:p>
-        </p:txBody>
-      </p:sp>
-      <p:sp>
-        <p:nvSpPr>
-          <p:cNvPr id="7" name="Rounded Rectangle 6"/>
-          <p:cNvSpPr/>
-          <p:nvPr/>
-        </p:nvSpPr>
-        <p:spPr>
-          <a:xfrm>
-            <a:off x="4343400" y="1828800"/>
-            <a:ext cx="3474720" cy="4389120"/>
-          </a:xfrm>
-          <a:prstGeom prst="roundRect">
-            <a:avLst/>
-          </a:prstGeom>
-          <a:solidFill>
-            <a:srgbClr val="FFFFFF"/>
-          </a:solidFill>
-          <a:ln w="31750">
-            <a:solidFill>
-              <a:srgbClr val="10B981"/>
-            </a:solidFill>
-          </a:ln>
-        </p:spPr>
-        <p:style>
-          <a:lnRef idx="1">
-            <a:schemeClr val="accent1"/>
-          </a:lnRef>
-          <a:fillRef idx="3">
-            <a:schemeClr val="accent1"/>
-          </a:fillRef>
-          <a:effectRef idx="2">
-            <a:schemeClr val="accent1"/>
-          </a:effectRef>
-          <a:fontRef idx="minor">
-            <a:schemeClr val="lt1"/>
-          </a:fontRef>
-        </p:style>
-        <p:txBody>
-          <a:bodyPr rtlCol="0" anchor="ctr" wrap="square"/>
-          <a:lstStyle/>
-          <a:p>
-            <a:pPr algn="ctr">
-              <a:defRPr sz="1100" b="1">
-                <a:solidFill>
-                  <a:srgbClr val="10B981"/>
-                </a:solidFill>
-              </a:defRPr>
-            </a:pPr>
-            <a:r>
-              <a:t>BENCHMARK SCENARIO</a:t>
-            </a:r>
-          </a:p>
-          <a:p>
-            <a:pPr algn="ctr">
-              <a:spcBef>
-                <a:spcPts val="600"/>
-              </a:spcBef>
-              <a:defRPr sz="1400" b="1">
-                <a:solidFill>
-                  <a:srgbClr val="0F172A"/>
-                </a:solidFill>
-              </a:defRPr>
-            </a:pPr>
-            <a:r>
-              <a:t>40% Adoption (Male Parity)</a:t>
-            </a:r>
-          </a:p>
-          <a:p>
-            <a:pPr algn="ctr">
-              <a:spcBef>
-                <a:spcPts val="1200"/>
-              </a:spcBef>
-              <a:defRPr sz="3200" b="1">
-                <a:solidFill>
-                  <a:srgbClr val="10B981"/>
-                </a:solidFill>
-              </a:defRPr>
-            </a:pPr>
-            <a:r>
-              <a:t>$85,000</a:t>
-            </a:r>
-          </a:p>
-          <a:p>
-            <a:pPr algn="ctr">
-              <a:defRPr sz="1000">
-                <a:solidFill>
-                  <a:srgbClr val="64748B"/>
-                </a:solidFill>
-              </a:defRPr>
-            </a:pPr>
-            <a:r>
-              <a:t>Additional Annual Revenue</a:t>
-            </a:r>
-          </a:p>
-          <a:p>
-            <a:pPr algn="ctr">
-              <a:spcBef>
-                <a:spcPts val="1200"/>
-              </a:spcBef>
-              <a:defRPr sz="1800" b="1">
-                <a:solidFill>
-                  <a:srgbClr val="0F172A"/>
-                </a:solidFill>
-              </a:defRPr>
-            </a:pPr>
-            <a:r>
-              <a:t>+36.5% Lift</a:t>
-            </a:r>
-          </a:p>
-          <a:p>
-            <a:pPr algn="ctr">
-              <a:spcBef>
-                <a:spcPts val="1600"/>
-              </a:spcBef>
-              <a:defRPr sz="1200">
-                <a:solidFill>
-                  <a:srgbClr val="1E293B"/>
-                </a:solidFill>
-              </a:defRPr>
-            </a:pPr>
-            <a:r>
-              <a:t>499 Female Subscribers</a:t>
-            </a:r>
-            <a:br/>
-            <a:r>
-              <a:t>Dedicated female VIP lifestyle club.</a:t>
-            </a:r>
-          </a:p>
-        </p:txBody>
-      </p:sp>
-      <p:sp>
-        <p:nvSpPr>
-          <p:cNvPr id="8" name="Rounded Rectangle 7"/>
-          <p:cNvSpPr/>
-          <p:nvPr/>
-        </p:nvSpPr>
-        <p:spPr>
-          <a:xfrm>
-            <a:off x="7955280" y="1828800"/>
-            <a:ext cx="3474720" cy="4389120"/>
-          </a:xfrm>
-          <a:prstGeom prst="roundRect">
-            <a:avLst/>
-          </a:prstGeom>
-          <a:solidFill>
-            <a:srgbClr val="FFFFFF"/>
-          </a:solidFill>
-          <a:ln w="31750">
-            <a:solidFill>
-              <a:srgbClr val="F59E0B"/>
-            </a:solidFill>
-          </a:ln>
-        </p:spPr>
-        <p:style>
-          <a:lnRef idx="1">
-            <a:schemeClr val="accent1"/>
-          </a:lnRef>
-          <a:fillRef idx="3">
-            <a:schemeClr val="accent1"/>
-          </a:fillRef>
-          <a:effectRef idx="2">
-            <a:schemeClr val="accent1"/>
-          </a:effectRef>
-          <a:fontRef idx="minor">
-            <a:schemeClr val="lt1"/>
-          </a:fontRef>
-        </p:style>
-        <p:txBody>
-          <a:bodyPr rtlCol="0" anchor="ctr" wrap="square"/>
-          <a:lstStyle/>
-          <a:p>
-            <a:pPr algn="ctr">
-              <a:defRPr sz="1100" b="1">
-                <a:solidFill>
-                  <a:srgbClr val="F59E0B"/>
-                </a:solidFill>
-              </a:defRPr>
-            </a:pPr>
-            <a:r>
-              <a:t>AGGRESSIVE SCENARIO</a:t>
-            </a:r>
-          </a:p>
-          <a:p>
-            <a:pPr algn="ctr">
-              <a:spcBef>
-                <a:spcPts val="600"/>
-              </a:spcBef>
-              <a:defRPr sz="1400" b="1">
-                <a:solidFill>
-                  <a:srgbClr val="0F172A"/>
-                </a:solidFill>
-              </a:defRPr>
-            </a:pPr>
-            <a:r>
-              <a:t>55% Penetration</a:t>
-            </a:r>
-          </a:p>
-          <a:p>
-            <a:pPr algn="ctr">
-              <a:spcBef>
-                <a:spcPts val="1200"/>
-              </a:spcBef>
-              <a:defRPr sz="3200" b="1">
-                <a:solidFill>
-                  <a:srgbClr val="F59E0B"/>
-                </a:solidFill>
-              </a:defRPr>
-            </a:pPr>
-            <a:r>
-              <a:t>$115,000</a:t>
-            </a:r>
-          </a:p>
-          <a:p>
-            <a:pPr algn="ctr">
-              <a:defRPr sz="1000">
-                <a:solidFill>
-                  <a:srgbClr val="64748B"/>
-                </a:solidFill>
-              </a:defRPr>
-            </a:pPr>
-            <a:r>
-              <a:t>Additional Annual Revenue</a:t>
-            </a:r>
-          </a:p>
-          <a:p>
-            <a:pPr algn="ctr">
-              <a:spcBef>
-                <a:spcPts val="1200"/>
-              </a:spcBef>
-              <a:defRPr sz="1800" b="1">
-                <a:solidFill>
-                  <a:srgbClr val="0F172A"/>
-                </a:solidFill>
-              </a:defRPr>
-            </a:pPr>
-            <a:r>
-              <a:t>+49.3% Lift</a:t>
-            </a:r>
-          </a:p>
-          <a:p>
-            <a:pPr algn="ctr">
-              <a:spcBef>
-                <a:spcPts val="1600"/>
-              </a:spcBef>
-              <a:defRPr sz="1200">
-                <a:solidFill>
-                  <a:srgbClr val="1E293B"/>
-                </a:solidFill>
-              </a:defRPr>
-            </a:pPr>
-            <a:r>
-              <a:t>686 Female Subscribers</a:t>
-            </a:r>
-            <a:br/>
-            <a:r>
-              <a:t>Multi-channel influencer launch.</a:t>
+              <a:t>• Implement exclusive concierge perks, early access drops, and anniversary rewards for Gold and Platinum tiers.</a:t>
             </a:r>
           </a:p>
         </p:txBody>

</xml_diff>